<commit_message>
Add notes on 2026.04.1
</commit_message>
<xml_diff>
--- a/slide/CA3060-4-Pipeline.pptx
+++ b/slide/CA3060-4-Pipeline.pptx
@@ -155,65 +155,6 @@
     </p:ext>
   </p:extLst>
 </p:presentation>
-</file>
-
-<file path=ppt/changesInfos/changesInfo1.xml><?xml version="1.0" encoding="utf-8"?>
-<pc:chgInfo xmlns:a="http://schemas.openxmlformats.org/drawingml/2006/main" xmlns:r="http://schemas.openxmlformats.org/officeDocument/2006/relationships" xmlns:ac="http://schemas.microsoft.com/office/drawing/2013/main/command" xmlns:pc="http://schemas.microsoft.com/office/powerpoint/2013/main/command">
-  <pc:docChgLst>
-    <pc:chgData name="Chaoyi Sun (SDS,124090550)" userId="7336b744-5857-42bc-9fde-1c1347a32774" providerId="ADAL" clId="{3A35FEB6-D186-4DFE-8550-C935A8639321}"/>
-    <pc:docChg chg="undo custSel modSld">
-      <pc:chgData name="Chaoyi Sun (SDS,124090550)" userId="7336b744-5857-42bc-9fde-1c1347a32774" providerId="ADAL" clId="{3A35FEB6-D186-4DFE-8550-C935A8639321}" dt="2026-03-17T13:37:45.988" v="5" actId="207"/>
-      <pc:docMkLst>
-        <pc:docMk/>
-      </pc:docMkLst>
-      <pc:sldChg chg="modSp mod">
-        <pc:chgData name="Chaoyi Sun (SDS,124090550)" userId="7336b744-5857-42bc-9fde-1c1347a32774" providerId="ADAL" clId="{3A35FEB6-D186-4DFE-8550-C935A8639321}" dt="2026-03-17T13:03:38.869" v="2" actId="20577"/>
-        <pc:sldMkLst>
-          <pc:docMk/>
-          <pc:sldMk cId="0" sldId="293"/>
-        </pc:sldMkLst>
-        <pc:spChg chg="mod">
-          <ac:chgData name="Chaoyi Sun (SDS,124090550)" userId="7336b744-5857-42bc-9fde-1c1347a32774" providerId="ADAL" clId="{3A35FEB6-D186-4DFE-8550-C935A8639321}" dt="2026-03-17T13:03:38.869" v="2" actId="20577"/>
-          <ac:spMkLst>
-            <pc:docMk/>
-            <pc:sldMk cId="0" sldId="293"/>
-            <ac:spMk id="353283" creationId="{00000000-0000-0000-0000-000000000000}"/>
-          </ac:spMkLst>
-        </pc:spChg>
-      </pc:sldChg>
-      <pc:sldChg chg="modSp mod">
-        <pc:chgData name="Chaoyi Sun (SDS,124090550)" userId="7336b744-5857-42bc-9fde-1c1347a32774" providerId="ADAL" clId="{3A35FEB6-D186-4DFE-8550-C935A8639321}" dt="2026-03-17T13:37:45.988" v="5" actId="207"/>
-        <pc:sldMkLst>
-          <pc:docMk/>
-          <pc:sldMk cId="0" sldId="527"/>
-        </pc:sldMkLst>
-        <pc:spChg chg="mod">
-          <ac:chgData name="Chaoyi Sun (SDS,124090550)" userId="7336b744-5857-42bc-9fde-1c1347a32774" providerId="ADAL" clId="{3A35FEB6-D186-4DFE-8550-C935A8639321}" dt="2026-03-17T13:37:45.988" v="5" actId="207"/>
-          <ac:spMkLst>
-            <pc:docMk/>
-            <pc:sldMk cId="0" sldId="527"/>
-            <ac:spMk id="3" creationId="{00000000-0000-0000-0000-000000000000}"/>
-          </ac:spMkLst>
-        </pc:spChg>
-      </pc:sldChg>
-      <pc:sldChg chg="modSp mod">
-        <pc:chgData name="Chaoyi Sun (SDS,124090550)" userId="7336b744-5857-42bc-9fde-1c1347a32774" providerId="ADAL" clId="{3A35FEB6-D186-4DFE-8550-C935A8639321}" dt="2026-03-17T13:37:45.854" v="4" actId="1076"/>
-        <pc:sldMkLst>
-          <pc:docMk/>
-          <pc:sldMk cId="220217435" sldId="673"/>
-        </pc:sldMkLst>
-        <pc:picChg chg="mod">
-          <ac:chgData name="Chaoyi Sun (SDS,124090550)" userId="7336b744-5857-42bc-9fde-1c1347a32774" providerId="ADAL" clId="{3A35FEB6-D186-4DFE-8550-C935A8639321}" dt="2026-03-17T13:37:45.854" v="4" actId="1076"/>
-          <ac:picMkLst>
-            <pc:docMk/>
-            <pc:sldMk cId="220217435" sldId="673"/>
-            <ac:picMk id="3" creationId="{E6005C9C-58FB-4DC1-B70D-7DDB4755C520}"/>
-          </ac:picMkLst>
-        </pc:picChg>
-      </pc:sldChg>
-    </pc:docChg>
-  </pc:docChgLst>
-</pc:chgInfo>
 </file>
 
 <file path=ppt/handoutMasters/handoutMaster1.xml><?xml version="1.0" encoding="utf-8"?>
@@ -16512,7 +16453,7 @@
               <a:buNone/>
             </a:pPr>
             <a:r>
-              <a:rPr kumimoji="1" lang="en-US" altLang="zh-TW" sz="1600" dirty="0">
+              <a:rPr kumimoji="1" lang="en-US" altLang="zh-TW" sz="1600">
                 <a:latin typeface="Times New Roman" panose="02020503050405090304" pitchFamily="18" charset="0"/>
                 <a:ea typeface="新細明體" panose="02020500000000000000" pitchFamily="18" charset="-120"/>
               </a:rPr>
@@ -45663,7 +45604,7 @@
       </p:par>
     </p:tnLst>
     <p:bldLst>
-      <p:bldP spid="2" grpId="0" animBg="1"/>
+      <p:bldP spid="2" grpId="0"/>
     </p:bldLst>
   </p:timing>
 </p:sld>

</xml_diff>